<commit_message>
TL;DR paper, agent skill, sgconvert, planner tutorial deck
- docs/tldr: five-page overview (problem, idea, CLI and planner, f-I and
  frozen-noise examples with a LIF model, formats, Gecko at the rig);
  make -C docs tldr builds docs/build/stimgen2-tldr.pdf
- skill/stimgen2: agent-agnostic skill (SKILL.md, references, checked
  examples, scripts sg_run / sgb_describe / sgb_plot / sgconvert);
  skill/build.py regenerates the parts derived from sg
- tools/sgconvert.py: describe .sgb in words; convert to csv, npz, mat,
  h5, atf, NEURON, Brian2, json
- docs/slides: planner tutorial deck with screenshots; fix_ids.js fixes
  duplicate shape ids from pptxgenjs that made PowerPoint ask for repair
  (both decks rebuilt)
- tests: test_convert.py and test_skill.py, run by make test
- README updated

Co-Authored-By: Claude Opus 5.5 <noreply@anthropic.com>
Claude-Session: https://claude.ai/code/session_01KpQ5h2LoYXqCX2PWWkoVvV
</commit_message>
<xml_diff>
--- a/docs/slides/StimGen2-tutorial.pptx
+++ b/docs/slides/StimGen2-tutorial.pptx
@@ -122,14 +122,14 @@
   <p:extLst>
     <p:ext uri="{521415D9-36F7-43E2-AB2F-B90AF26B5E84}">
       <p14:sectionLst xmlns:p14="http://schemas.microsoft.com/office/powerpoint/2010/main">
-        <p14:section name="Introduction" id="{f8e86918-3851-8fe0-919e-b6ad76cfd580}">
+        <p14:section name="Introduction" id="{84203976-a8a0-8436-5126-c012d532d1cf}">
           <p14:sldIdLst>
             <p14:sldId id="256"/>
             <p14:sldId id="257"/>
             <p14:sldId id="258"/>
           </p14:sldIdLst>
         </p14:section>
-        <p14:section name="Writing stimuli" id="{7324dcf1-7e68-9c7c-3a03-9e0804340884}">
+        <p14:section name="Writing stimuli" id="{3e5192e2-70f3-9ffe-bd71-43fcbaddb823}">
           <p14:sldIdLst>
             <p14:sldId id="259"/>
             <p14:sldId id="260"/>
@@ -138,21 +138,21 @@
             <p14:sldId id="263"/>
           </p14:sldIdLst>
         </p14:section>
-        <p14:section name="Experiments" id="{4dc0b1a5-4788-9e76-fbb5-ed560a533242}">
+        <p14:section name="Experiments" id="{4e162e52-ac55-0c82-8027-f8908c18fd86}">
           <p14:sldIdLst>
             <p14:sldId id="264"/>
             <p14:sldId id="265"/>
             <p14:sldId id="266"/>
           </p14:sldIdLst>
         </p14:section>
-        <p14:section name="On the rig" id="{457e45a1-8de8-4f0f-d04d-7253b0dce655}">
+        <p14:section name="On the rig" id="{73470776-031d-b849-e214-1eb1201b56fe}">
           <p14:sldIdLst>
             <p14:sldId id="267"/>
             <p14:sldId id="268"/>
             <p14:sldId id="269"/>
           </p14:sldIdLst>
         </p14:section>
-        <p14:section name="Wrap-up" id="{e633b640-c586-efa2-99d2-710f1c1f2ee1}">
+        <p14:section name="Wrap-up" id="{c7eadd9b-06ed-cdf2-5d31-305567e4732f}">
           <p14:sldIdLst>
             <p14:sldId id="270"/>
             <p14:sldId id="271"/>
@@ -8025,7 +8025,7 @@
       </p:sp>
       <p:sp>
         <p:nvSpPr>
-          <p:cNvPr id="25" name="Slide Number Placeholder 0"/>
+          <p:cNvPr id="27" name="Slide Number Placeholder 0"/>
           <p:cNvSpPr>
             <a:spLocks noGrp="1"/>
           </p:cNvSpPr>
@@ -11051,7 +11051,7 @@
       </p:sp>
       <p:sp>
         <p:nvSpPr>
-          <p:cNvPr id="25" name="Slide Number Placeholder 0"/>
+          <p:cNvPr id="39" name="Slide Number Placeholder 0"/>
           <p:cNvSpPr>
             <a:spLocks noGrp="1"/>
           </p:cNvSpPr>

</xml_diff>